<commit_message>
LION CITY: rename Sarah Chen to Sophii Weiming
Updated in the Studio One-Pager PDF, the pitch deck (slides 6, 8, 10 and
speaker notes), and the Passport page.

Co-Authored-By: Claude Opus 5.5 <noreply@anthropic.com>
Claude-Session: https://claude.ai/code/session_019Mre8MowFPXXHqKN7k1c4f
</commit_message>
<xml_diff>
--- a/pitch-decks/lion-city-pitch-deck.pptx
+++ b/pitch-decks/lion-city-pitch-deck.pptx
@@ -593,7 +593,7 @@
           <a:lstStyle xmlns:a="http://schemas.openxmlformats.org/drawingml/2006/main"/>
           <a:p xmlns:a="http://schemas.openxmlformats.org/drawingml/2006/main">
             <a:r>
-              <a:t>Source: supplied four-page story treatment and Pitch Deck Creation conversation. Positioning for a premium action-thriller audience. Franchise potential is grounded in Sarah’s Gray Cell and the final Seoul anomaly; the core story resolves the Singapore crisis. No market size, budget or buyer commitment is claimed. Visuals are generated concept artwork; no actors are depicted as attached.</a:t>
+              <a:t>Source: supplied four-page story treatment and Pitch Deck Creation conversation. Positioning for a premium action-thriller audience. Franchise potential is grounded in Sophii’s Gray Cell and the final Seoul anomaly; the core story resolves the Singapore crisis. No market size, budget or buyer commitment is claimed. Visuals are generated concept artwork; no actors are depicted as attached.</a:t>
             </a:r>
           </a:p>
         </p:txBody>
@@ -733,7 +733,7 @@
           <a:lstStyle xmlns:a="http://schemas.openxmlformats.org/drawingml/2006/main"/>
           <a:p xmlns:a="http://schemas.openxmlformats.org/drawingml/2006/main">
             <a:r>
-              <a:t>Source: supplied four-page story treatment and Pitch Deck Creation conversation. Jack Vance is a DSS agent protecting a U.S. Senator. Sarah Chen must confront her father’s legacy. Julian Vane steals the Sovereign Drive to trigger The Reset. Visuals are generated concept artwork; no actors are depicted as attached.</a:t>
+              <a:t>Source: supplied four-page story treatment and Pitch Deck Creation conversation. Jack Vance is a DSS agent protecting a U.S. Senator. Sophii Weiming must confront her father’s legacy. Julian Vane steals the Sovereign Drive to trigger The Reset. Visuals are generated concept artwork; no actors are depicted as attached.</a:t>
             </a:r>
           </a:p>
         </p:txBody>
@@ -1153,7 +1153,7 @@
           <a:lstStyle xmlns:a="http://schemas.openxmlformats.org/drawingml/2006/main"/>
           <a:p xmlns:a="http://schemas.openxmlformats.org/drawingml/2006/main">
             <a:r>
-              <a:t>Source: supplied four-page story treatment and Pitch Deck Creation conversation. Act I: Jewel Changi, Marina Bay Financial Centre, Lau Pa Sat. Act II: stormwater tunnels, Bukit Timah, Little India, Supertree Grove light-and-mist escape. Act III: two-path Marina Bay Sands assault; Sarah defeats Sloane with inherited silat, destroys the terminal at 98%; Jack couples the Sovereign Drive to a lightning rod. Grid reboots; Sarah establishes the Gray Cell; Seoul anomaly seeds continuation. Visuals are generated concept artwork; no actors are depicted as attached.</a:t>
+              <a:t>Source: supplied four-page story treatment and Pitch Deck Creation conversation. Act I: Jewel Changi, Marina Bay Financial Centre, Lau Pa Sat. Act II: stormwater tunnels, Bukit Timah, Little India, Supertree Grove light-and-mist escape. Act III: two-path Marina Bay Sands assault; Sophii defeats Sloane with inherited silat, destroys the terminal at 98%; Jack couples the Sovereign Drive to a lightning rod. Grid reboots; Sophii establishes the Gray Cell; Seoul anomaly seeds continuation. Visuals are generated concept artwork; no actors are depicted as attached.</a:t>
             </a:r>
           </a:p>
         </p:txBody>
@@ -2717,7 +2717,7 @@
                 <a:ea typeface="Arial"/>
                 <a:cs typeface="Arial"/>
               </a:rPr>
-              <a:t>SARAH CHEN</a:t>
+              <a:t>SOPHII WEIMING</a:t>
             </a:r>
           </a:p>
           <a:p xmlns:a="http://schemas.openxmlformats.org/drawingml/2006/main">
@@ -5666,7 +5666,7 @@
                 <a:ea typeface="Arial Narrow"/>
                 <a:cs typeface="Arial Narrow"/>
               </a:rPr>
-              <a:t>SARAH CHEN</a:t>
+              <a:t>SOPHII WEIMING</a:t>
             </a:r>
           </a:p>
         </p:txBody>
@@ -7085,7 +7085,7 @@
                 <a:ea typeface="Arial"/>
                 <a:cs typeface="Arial"/>
               </a:rPr>
-              <a:t>Sarah sees the lie.</a:t>
+              <a:t>Sophii sees the lie.</a:t>
             </a:r>
           </a:p>
         </p:txBody>
@@ -7382,7 +7382,7 @@
                 <a:ea typeface="Arial"/>
                 <a:cs typeface="Arial"/>
               </a:rPr>
-              <a:t>Sarah refuses vengeance.</a:t>
+              <a:t>Sophii refuses vengeance.</a:t>
             </a:r>
           </a:p>
           <a:p xmlns:a="http://schemas.openxmlformats.org/drawingml/2006/main">

</xml_diff>

<commit_message>
LION CITY: rename Sarah Chen to Sophii Weiming (#14)
Updated in the Studio One-Pager PDF, the pitch deck (slides 6, 8, 10 and
speaker notes), and the Passport page.


Claude-Session: https://claude.ai/code/session_019Mre8MowFPXXHqKN7k1c4f

Co-authored-by: Claude Opus 5.5 <noreply@anthropic.com>
</commit_message>
<xml_diff>
--- a/pitch-decks/lion-city-pitch-deck.pptx
+++ b/pitch-decks/lion-city-pitch-deck.pptx
@@ -593,7 +593,7 @@
           <a:lstStyle xmlns:a="http://schemas.openxmlformats.org/drawingml/2006/main"/>
           <a:p xmlns:a="http://schemas.openxmlformats.org/drawingml/2006/main">
             <a:r>
-              <a:t>Source: supplied four-page story treatment and Pitch Deck Creation conversation. Positioning for a premium action-thriller audience. Franchise potential is grounded in Sarah’s Gray Cell and the final Seoul anomaly; the core story resolves the Singapore crisis. No market size, budget or buyer commitment is claimed. Visuals are generated concept artwork; no actors are depicted as attached.</a:t>
+              <a:t>Source: supplied four-page story treatment and Pitch Deck Creation conversation. Positioning for a premium action-thriller audience. Franchise potential is grounded in Sophii’s Gray Cell and the final Seoul anomaly; the core story resolves the Singapore crisis. No market size, budget or buyer commitment is claimed. Visuals are generated concept artwork; no actors are depicted as attached.</a:t>
             </a:r>
           </a:p>
         </p:txBody>
@@ -733,7 +733,7 @@
           <a:lstStyle xmlns:a="http://schemas.openxmlformats.org/drawingml/2006/main"/>
           <a:p xmlns:a="http://schemas.openxmlformats.org/drawingml/2006/main">
             <a:r>
-              <a:t>Source: supplied four-page story treatment and Pitch Deck Creation conversation. Jack Vance is a DSS agent protecting a U.S. Senator. Sarah Chen must confront her father’s legacy. Julian Vane steals the Sovereign Drive to trigger The Reset. Visuals are generated concept artwork; no actors are depicted as attached.</a:t>
+              <a:t>Source: supplied four-page story treatment and Pitch Deck Creation conversation. Jack Vance is a DSS agent protecting a U.S. Senator. Sophii Weiming must confront her father’s legacy. Julian Vane steals the Sovereign Drive to trigger The Reset. Visuals are generated concept artwork; no actors are depicted as attached.</a:t>
             </a:r>
           </a:p>
         </p:txBody>
@@ -1153,7 +1153,7 @@
           <a:lstStyle xmlns:a="http://schemas.openxmlformats.org/drawingml/2006/main"/>
           <a:p xmlns:a="http://schemas.openxmlformats.org/drawingml/2006/main">
             <a:r>
-              <a:t>Source: supplied four-page story treatment and Pitch Deck Creation conversation. Act I: Jewel Changi, Marina Bay Financial Centre, Lau Pa Sat. Act II: stormwater tunnels, Bukit Timah, Little India, Supertree Grove light-and-mist escape. Act III: two-path Marina Bay Sands assault; Sarah defeats Sloane with inherited silat, destroys the terminal at 98%; Jack couples the Sovereign Drive to a lightning rod. Grid reboots; Sarah establishes the Gray Cell; Seoul anomaly seeds continuation. Visuals are generated concept artwork; no actors are depicted as attached.</a:t>
+              <a:t>Source: supplied four-page story treatment and Pitch Deck Creation conversation. Act I: Jewel Changi, Marina Bay Financial Centre, Lau Pa Sat. Act II: stormwater tunnels, Bukit Timah, Little India, Supertree Grove light-and-mist escape. Act III: two-path Marina Bay Sands assault; Sophii defeats Sloane with inherited silat, destroys the terminal at 98%; Jack couples the Sovereign Drive to a lightning rod. Grid reboots; Sophii establishes the Gray Cell; Seoul anomaly seeds continuation. Visuals are generated concept artwork; no actors are depicted as attached.</a:t>
             </a:r>
           </a:p>
         </p:txBody>
@@ -2717,7 +2717,7 @@
                 <a:ea typeface="Arial"/>
                 <a:cs typeface="Arial"/>
               </a:rPr>
-              <a:t>SARAH CHEN</a:t>
+              <a:t>SOPHII WEIMING</a:t>
             </a:r>
           </a:p>
           <a:p xmlns:a="http://schemas.openxmlformats.org/drawingml/2006/main">
@@ -5666,7 +5666,7 @@
                 <a:ea typeface="Arial Narrow"/>
                 <a:cs typeface="Arial Narrow"/>
               </a:rPr>
-              <a:t>SARAH CHEN</a:t>
+              <a:t>SOPHII WEIMING</a:t>
             </a:r>
           </a:p>
         </p:txBody>
@@ -7085,7 +7085,7 @@
                 <a:ea typeface="Arial"/>
                 <a:cs typeface="Arial"/>
               </a:rPr>
-              <a:t>Sarah sees the lie.</a:t>
+              <a:t>Sophii sees the lie.</a:t>
             </a:r>
           </a:p>
         </p:txBody>
@@ -7382,7 +7382,7 @@
                 <a:ea typeface="Arial"/>
                 <a:cs typeface="Arial"/>
               </a:rPr>
-              <a:t>Sarah refuses vengeance.</a:t>
+              <a:t>Sophii refuses vengeance.</a:t>
             </a:r>
           </a:p>
           <a:p xmlns:a="http://schemas.openxmlformats.org/drawingml/2006/main">

</xml_diff>